<commit_message>
work on diffpure and bld purification.
</commit_message>
<xml_diff>
--- a/CRIS_week16.pptx
+++ b/CRIS_week16.pptx
@@ -8,9 +8,8 @@
     <p:sldId id="256" r:id="rId2"/>
     <p:sldId id="257" r:id="rId3"/>
     <p:sldId id="258" r:id="rId4"/>
-    <p:sldId id="259" r:id="rId5"/>
-    <p:sldId id="260" r:id="rId6"/>
-    <p:sldId id="261" r:id="rId7"/>
+    <p:sldId id="260" r:id="rId5"/>
+    <p:sldId id="261" r:id="rId6"/>
   </p:sldIdLst>
   <p:sldSz cx="12192000" cy="6858000"/>
   <p:notesSz cx="6858000" cy="9144000"/>
@@ -264,7 +263,7 @@
           <a:p>
             <a:fld id="{69C5C8C9-4E2B-41F8-8A8B-726541980F7E}" type="datetimeFigureOut">
               <a:rPr lang="zh-CN" altLang="en-US" smtClean="0"/>
-              <a:t>2026/7/10</a:t>
+              <a:t>2026/7/12</a:t>
             </a:fld>
             <a:endParaRPr lang="zh-CN" altLang="en-US"/>
           </a:p>
@@ -462,7 +461,7 @@
           <a:p>
             <a:fld id="{69C5C8C9-4E2B-41F8-8A8B-726541980F7E}" type="datetimeFigureOut">
               <a:rPr lang="zh-CN" altLang="en-US" smtClean="0"/>
-              <a:t>2026/7/10</a:t>
+              <a:t>2026/7/12</a:t>
             </a:fld>
             <a:endParaRPr lang="zh-CN" altLang="en-US"/>
           </a:p>
@@ -670,7 +669,7 @@
           <a:p>
             <a:fld id="{69C5C8C9-4E2B-41F8-8A8B-726541980F7E}" type="datetimeFigureOut">
               <a:rPr lang="zh-CN" altLang="en-US" smtClean="0"/>
-              <a:t>2026/7/10</a:t>
+              <a:t>2026/7/12</a:t>
             </a:fld>
             <a:endParaRPr lang="zh-CN" altLang="en-US"/>
           </a:p>
@@ -868,7 +867,7 @@
           <a:p>
             <a:fld id="{69C5C8C9-4E2B-41F8-8A8B-726541980F7E}" type="datetimeFigureOut">
               <a:rPr lang="zh-CN" altLang="en-US" smtClean="0"/>
-              <a:t>2026/7/10</a:t>
+              <a:t>2026/7/12</a:t>
             </a:fld>
             <a:endParaRPr lang="zh-CN" altLang="en-US"/>
           </a:p>
@@ -1143,7 +1142,7 @@
           <a:p>
             <a:fld id="{69C5C8C9-4E2B-41F8-8A8B-726541980F7E}" type="datetimeFigureOut">
               <a:rPr lang="zh-CN" altLang="en-US" smtClean="0"/>
-              <a:t>2026/7/10</a:t>
+              <a:t>2026/7/12</a:t>
             </a:fld>
             <a:endParaRPr lang="zh-CN" altLang="en-US"/>
           </a:p>
@@ -1408,7 +1407,7 @@
           <a:p>
             <a:fld id="{69C5C8C9-4E2B-41F8-8A8B-726541980F7E}" type="datetimeFigureOut">
               <a:rPr lang="zh-CN" altLang="en-US" smtClean="0"/>
-              <a:t>2026/7/10</a:t>
+              <a:t>2026/7/12</a:t>
             </a:fld>
             <a:endParaRPr lang="zh-CN" altLang="en-US"/>
           </a:p>
@@ -1820,7 +1819,7 @@
           <a:p>
             <a:fld id="{69C5C8C9-4E2B-41F8-8A8B-726541980F7E}" type="datetimeFigureOut">
               <a:rPr lang="zh-CN" altLang="en-US" smtClean="0"/>
-              <a:t>2026/7/10</a:t>
+              <a:t>2026/7/12</a:t>
             </a:fld>
             <a:endParaRPr lang="zh-CN" altLang="en-US"/>
           </a:p>
@@ -1961,7 +1960,7 @@
           <a:p>
             <a:fld id="{69C5C8C9-4E2B-41F8-8A8B-726541980F7E}" type="datetimeFigureOut">
               <a:rPr lang="zh-CN" altLang="en-US" smtClean="0"/>
-              <a:t>2026/7/10</a:t>
+              <a:t>2026/7/12</a:t>
             </a:fld>
             <a:endParaRPr lang="zh-CN" altLang="en-US"/>
           </a:p>
@@ -2074,7 +2073,7 @@
           <a:p>
             <a:fld id="{69C5C8C9-4E2B-41F8-8A8B-726541980F7E}" type="datetimeFigureOut">
               <a:rPr lang="zh-CN" altLang="en-US" smtClean="0"/>
-              <a:t>2026/7/10</a:t>
+              <a:t>2026/7/12</a:t>
             </a:fld>
             <a:endParaRPr lang="zh-CN" altLang="en-US"/>
           </a:p>
@@ -2385,7 +2384,7 @@
           <a:p>
             <a:fld id="{69C5C8C9-4E2B-41F8-8A8B-726541980F7E}" type="datetimeFigureOut">
               <a:rPr lang="zh-CN" altLang="en-US" smtClean="0"/>
-              <a:t>2026/7/10</a:t>
+              <a:t>2026/7/12</a:t>
             </a:fld>
             <a:endParaRPr lang="zh-CN" altLang="en-US"/>
           </a:p>
@@ -2673,7 +2672,7 @@
           <a:p>
             <a:fld id="{69C5C8C9-4E2B-41F8-8A8B-726541980F7E}" type="datetimeFigureOut">
               <a:rPr lang="zh-CN" altLang="en-US" smtClean="0"/>
-              <a:t>2026/7/10</a:t>
+              <a:t>2026/7/12</a:t>
             </a:fld>
             <a:endParaRPr lang="zh-CN" altLang="en-US"/>
           </a:p>
@@ -2914,7 +2913,7 @@
           <a:p>
             <a:fld id="{69C5C8C9-4E2B-41F8-8A8B-726541980F7E}" type="datetimeFigureOut">
               <a:rPr lang="zh-CN" altLang="en-US" smtClean="0"/>
-              <a:t>2026/7/10</a:t>
+              <a:t>2026/7/12</a:t>
             </a:fld>
             <a:endParaRPr lang="zh-CN" altLang="en-US"/>
           </a:p>
@@ -3377,7 +3376,7 @@
           <a:bodyPr/>
           <a:lstStyle/>
           <a:p>
-            <a:endParaRPr lang="zh-CN" altLang="en-US"/>
+            <a:endParaRPr lang="zh-CN" altLang="en-US" dirty="0"/>
           </a:p>
         </p:txBody>
       </p:sp>
@@ -3403,14 +3402,83 @@
         </p:blipFill>
         <p:spPr>
           <a:xfrm>
-            <a:off x="1613647" y="1457418"/>
-            <a:ext cx="8633012" cy="3597088"/>
+            <a:off x="0" y="0"/>
+            <a:ext cx="9254440" cy="3856017"/>
           </a:xfrm>
           <a:prstGeom prst="rect">
             <a:avLst/>
           </a:prstGeom>
         </p:spPr>
       </p:pic>
+      <p:sp>
+        <p:nvSpPr>
+          <p:cNvPr id="4" name="文本框 3">
+            <a:extLst>
+              <a:ext uri="{FF2B5EF4-FFF2-40B4-BE49-F238E27FC236}">
+                <a16:creationId xmlns:a16="http://schemas.microsoft.com/office/drawing/2014/main" id="{150409BF-68AB-CD8F-9F65-0D067A57D46A}"/>
+              </a:ext>
+            </a:extLst>
+          </p:cNvPr>
+          <p:cNvSpPr txBox="1"/>
+          <p:nvPr/>
+        </p:nvSpPr>
+        <p:spPr>
+          <a:xfrm>
+            <a:off x="616944" y="4060587"/>
+            <a:ext cx="5888516" cy="1754326"/>
+          </a:xfrm>
+          <a:prstGeom prst="rect">
+            <a:avLst/>
+          </a:prstGeom>
+          <a:noFill/>
+        </p:spPr>
+        <p:txBody>
+          <a:bodyPr wrap="square" rtlCol="0">
+            <a:spAutoFit/>
+          </a:bodyPr>
+          <a:lstStyle/>
+          <a:p>
+            <a:r>
+              <a:rPr lang="en-US" altLang="zh-CN" dirty="0"/>
+              <a:t>Image1</a:t>
+            </a:r>
+            <a:r>
+              <a:rPr lang="zh-CN" altLang="en-US" dirty="0"/>
+              <a:t>比较敏感，</a:t>
+            </a:r>
+            <a:r>
+              <a:rPr lang="en-US" altLang="zh-CN" dirty="0"/>
+              <a:t>5</a:t>
+            </a:r>
+            <a:r>
+              <a:rPr lang="zh-CN" altLang="en-US" dirty="0"/>
+              <a:t>比较鲁棒。</a:t>
+            </a:r>
+            <a:endParaRPr lang="en-US" altLang="zh-CN" dirty="0"/>
+          </a:p>
+          <a:p>
+            <a:r>
+              <a:rPr lang="zh-CN" altLang="en-US" dirty="0"/>
+              <a:t>参数下降速率在放缓，符合扩散模型</a:t>
+            </a:r>
+            <a:r>
+              <a:rPr lang="en-US" altLang="zh-CN" dirty="0"/>
+              <a:t>t</a:t>
+            </a:r>
+            <a:r>
+              <a:rPr lang="zh-CN" altLang="en-US" dirty="0"/>
+              <a:t>越大，添加噪声能破坏的信息越少的特性。</a:t>
+            </a:r>
+            <a:endParaRPr lang="en-US" altLang="zh-CN" dirty="0"/>
+          </a:p>
+          <a:p>
+            <a:r>
+              <a:rPr lang="zh-CN" altLang="en-US" dirty="0"/>
+              <a:t>参数变化的曲线，可以用来对比我们的净化模型的退化曲线，如果我们的曲线更加平缓，就体现了我们框架的创新之处。</a:t>
+            </a:r>
+          </a:p>
+        </p:txBody>
+      </p:sp>
     </p:spTree>
     <p:extLst>
       <p:ext uri="{BB962C8B-B14F-4D97-AF65-F5344CB8AC3E}">
@@ -3490,14 +3558,115 @@
         </p:blipFill>
         <p:spPr>
           <a:xfrm>
-            <a:off x="2148715" y="1825625"/>
-            <a:ext cx="7894570" cy="4351338"/>
+            <a:off x="788132" y="365125"/>
+            <a:ext cx="6531758" cy="3600182"/>
           </a:xfrm>
           <a:prstGeom prst="rect">
             <a:avLst/>
           </a:prstGeom>
         </p:spPr>
       </p:pic>
+      <p:sp>
+        <p:nvSpPr>
+          <p:cNvPr id="3" name="文本框 2">
+            <a:extLst>
+              <a:ext uri="{FF2B5EF4-FFF2-40B4-BE49-F238E27FC236}">
+                <a16:creationId xmlns:a16="http://schemas.microsoft.com/office/drawing/2014/main" id="{84FF2F88-1301-4111-4EC6-AFC2C392AEA9}"/>
+              </a:ext>
+            </a:extLst>
+          </p:cNvPr>
+          <p:cNvSpPr txBox="1"/>
+          <p:nvPr/>
+        </p:nvSpPr>
+        <p:spPr>
+          <a:xfrm>
+            <a:off x="7541045" y="2252949"/>
+            <a:ext cx="4252511" cy="2862322"/>
+          </a:xfrm>
+          <a:prstGeom prst="rect">
+            <a:avLst/>
+          </a:prstGeom>
+          <a:noFill/>
+        </p:spPr>
+        <p:txBody>
+          <a:bodyPr wrap="square" rtlCol="0">
+            <a:spAutoFit/>
+          </a:bodyPr>
+          <a:lstStyle/>
+          <a:p>
+            <a:r>
+              <a:rPr lang="zh-CN" altLang="en-US" dirty="0"/>
+              <a:t>训练得到一个</a:t>
+            </a:r>
+            <a:r>
+              <a:rPr lang="zh-CN" altLang="zh-CN" dirty="0"/>
+              <a:t>把图像压成2048-bit二值编码、并且能较好重建回图像的</a:t>
+            </a:r>
+            <a:r>
+              <a:rPr lang="en-US" altLang="zh-CN" dirty="0"/>
+              <a:t>encoder</a:t>
+            </a:r>
+            <a:r>
+              <a:rPr lang="zh-CN" altLang="en-US" dirty="0"/>
+              <a:t>，最终重建图片的</a:t>
+            </a:r>
+            <a:r>
+              <a:rPr lang="en-US" altLang="zh-CN" dirty="0"/>
+              <a:t>PSNR</a:t>
+            </a:r>
+            <a:r>
+              <a:rPr lang="zh-CN" altLang="en-US" dirty="0"/>
+              <a:t>在</a:t>
+            </a:r>
+            <a:r>
+              <a:rPr lang="en-US" altLang="zh-CN" dirty="0"/>
+              <a:t>23dB</a:t>
+            </a:r>
+            <a:r>
+              <a:rPr lang="zh-CN" altLang="en-US" dirty="0"/>
+              <a:t>左右。</a:t>
+            </a:r>
+            <a:endParaRPr lang="en-US" altLang="zh-CN" dirty="0"/>
+          </a:p>
+          <a:p>
+            <a:r>
+              <a:rPr lang="zh-CN" altLang="en-US" dirty="0"/>
+              <a:t>然后将图片编码为二值潜在</a:t>
+            </a:r>
+            <a:r>
+              <a:rPr lang="en-US" altLang="zh-CN" dirty="0"/>
+              <a:t>z0</a:t>
+            </a:r>
+            <a:r>
+              <a:rPr lang="zh-CN" altLang="en-US" dirty="0"/>
+              <a:t>，用伯努利扩散的方式对</a:t>
+            </a:r>
+            <a:r>
+              <a:rPr lang="en-US" altLang="zh-CN" dirty="0"/>
+              <a:t>z0</a:t>
+            </a:r>
+            <a:r>
+              <a:rPr lang="zh-CN" altLang="en-US" dirty="0"/>
+              <a:t>进行随机翻转，检测模型从被反转的编码中还原原始编码的能力。</a:t>
+            </a:r>
+            <a:endParaRPr lang="en-US" altLang="zh-CN" dirty="0"/>
+          </a:p>
+          <a:p>
+            <a:r>
+              <a:rPr lang="zh-CN" altLang="en-US" dirty="0"/>
+              <a:t>当前的攻击还不是成熟的对抗攻击，但</a:t>
+            </a:r>
+            <a:r>
+              <a:rPr lang="en-US" altLang="zh-CN" dirty="0"/>
+              <a:t>t</a:t>
+            </a:r>
+            <a:r>
+              <a:rPr lang="zh-CN" altLang="en-US" dirty="0"/>
+              <a:t>缓慢的下降曲线可以说明方法本身的可行性。</a:t>
+            </a:r>
+          </a:p>
+        </p:txBody>
+      </p:sp>
     </p:spTree>
     <p:extLst>
       <p:ext uri="{BB962C8B-B14F-4D97-AF65-F5344CB8AC3E}">
@@ -3546,10 +3715,20 @@
         </p:nvSpPr>
         <p:spPr/>
         <p:txBody>
-          <a:bodyPr/>
-          <a:lstStyle/>
-          <a:p>
-            <a:endParaRPr lang="zh-CN" altLang="en-US"/>
+          <a:bodyPr>
+            <a:normAutofit/>
+          </a:bodyPr>
+          <a:lstStyle/>
+          <a:p>
+            <a:r>
+              <a:rPr lang="zh-CN" altLang="zh-CN" sz="2400" dirty="0"/>
+              <a:t>真实图像→PGD攻击→encoder→净化→decoder→检测器mAP</a:t>
+            </a:r>
+            <a:r>
+              <a:rPr lang="en-US" altLang="zh-CN" sz="2400" dirty="0"/>
+              <a:t> pipeline</a:t>
+            </a:r>
+            <a:endParaRPr lang="zh-CN" altLang="en-US" sz="2400" dirty="0"/>
           </a:p>
         </p:txBody>
       </p:sp>
@@ -3577,99 +3756,69 @@
         </p:spPr>
         <p:txBody>
           <a:bodyPr>
-            <a:normAutofit fontScale="92500" lnSpcReduction="10000"/>
+            <a:normAutofit/>
           </a:bodyPr>
           <a:lstStyle/>
           <a:p>
             <a:r>
-              <a:rPr lang="zh-CN" altLang="zh-CN" sz="1400" dirty="0"/>
-              <a:t>[clean upper bound] </a:t>
-            </a:r>
-            <a:endParaRPr lang="en-US" altLang="zh-CN" sz="1400" dirty="0"/>
-          </a:p>
-          <a:p>
-            <a:r>
-              <a:rPr lang="zh-CN" altLang="zh-CN" sz="1400" dirty="0"/>
-              <a:t>t*= 5 bit_acc=0.9994 </a:t>
-            </a:r>
-            <a:endParaRPr lang="en-US" altLang="zh-CN" sz="1400" dirty="0"/>
-          </a:p>
-          <a:p>
-            <a:r>
-              <a:rPr lang="zh-CN" altLang="zh-CN" sz="1400" dirty="0"/>
-              <a:t>t*= 10 bit_acc=0.9984 </a:t>
-            </a:r>
-            <a:endParaRPr lang="en-US" altLang="zh-CN" sz="1400" dirty="0"/>
-          </a:p>
-          <a:p>
-            <a:r>
-              <a:rPr lang="zh-CN" altLang="zh-CN" sz="1400" dirty="0"/>
-              <a:t>t*= 20 bit_acc=0.9945 </a:t>
-            </a:r>
-            <a:endParaRPr lang="en-US" altLang="zh-CN" sz="1400" dirty="0"/>
-          </a:p>
-          <a:p>
-            <a:r>
-              <a:rPr lang="zh-CN" altLang="zh-CN" sz="1400" dirty="0"/>
-              <a:t>t*= 40 bit_acc=0.9808 </a:t>
-            </a:r>
-            <a:endParaRPr lang="en-US" altLang="zh-CN" sz="1400" dirty="0"/>
-          </a:p>
-          <a:p>
-            <a:r>
-              <a:rPr lang="zh-CN" altLang="zh-CN" sz="1400" dirty="0"/>
-              <a:t>t*= 80 bit_acc=0.9395 </a:t>
-            </a:r>
-            <a:endParaRPr lang="en-US" altLang="zh-CN" sz="1400" dirty="0"/>
-          </a:p>
-          <a:p>
-            <a:r>
-              <a:rPr lang="zh-CN" altLang="zh-CN" sz="1400" dirty="0"/>
-              <a:t>[flip=3% baseline=0.9698]</a:t>
-            </a:r>
-            <a:endParaRPr lang="en-US" altLang="zh-CN" sz="1400" dirty="0"/>
-          </a:p>
-          <a:p>
-            <a:r>
-              <a:rPr lang="zh-CN" altLang="zh-CN" sz="1400" dirty="0"/>
-              <a:t> t*= 5 bit_acc=0.9914 delta=+0.0216 </a:t>
-            </a:r>
-            <a:endParaRPr lang="en-US" altLang="zh-CN" sz="1400" dirty="0"/>
-          </a:p>
-          <a:p>
-            <a:r>
-              <a:rPr lang="zh-CN" altLang="zh-CN" sz="1400" dirty="0"/>
-              <a:t>t*= 10 bit_acc=0.9903 delta=+0.0205</a:t>
-            </a:r>
-            <a:endParaRPr lang="en-US" altLang="zh-CN" sz="1400" dirty="0"/>
-          </a:p>
-          <a:p>
-            <a:r>
-              <a:rPr lang="zh-CN" altLang="zh-CN" sz="1400" dirty="0"/>
-              <a:t>t*= 20 bit_acc=0.9865 delta=+0.0167 </a:t>
-            </a:r>
-            <a:endParaRPr lang="en-US" altLang="zh-CN" sz="1400" dirty="0"/>
-          </a:p>
-          <a:p>
-            <a:r>
-              <a:rPr lang="zh-CN" altLang="zh-CN" sz="1400" dirty="0"/>
-              <a:t>t*= 40 bit_acc=0.9737 delta=+0.0039 </a:t>
-            </a:r>
-            <a:endParaRPr lang="en-US" altLang="zh-CN" sz="1400" dirty="0"/>
-          </a:p>
-          <a:p>
-            <a:r>
-              <a:rPr lang="zh-CN" altLang="zh-CN" sz="1400" dirty="0"/>
-              <a:t>t*= 80 bit_acc=0.9347 delta=-0.0351 </a:t>
-            </a:r>
-            <a:endParaRPr lang="en-US" altLang="zh-CN" sz="1400" dirty="0"/>
-          </a:p>
-          <a:p>
-            <a:r>
-              <a:rPr lang="zh-CN" altLang="zh-CN" sz="1400" dirty="0"/>
-              <a:t>[flip=10% baseline=0.8994] t*= 5 bit_acc=0.9686 delta=+0.0692 t*= 10 bit_acc=0.9676 delta=+0.0681 t*= 20 bit_acc=0.9648 delta=+0.0653 t*= 40 bit_acc=0.9552 delta=+0.0558 t*= 80 bit_acc=0.9216 delta=+0.0222 [flip=20% baseline=0.8001] t*= 5 bit_acc=0.9281 delta=+0.1280 t*= 10 bit_acc=0.9269 delta=+0.1268 t*= 20 bit_acc=0.9251 delta=+0.1250 t*= 40 bit_acc=0.9191 delta=+0.1190 t*= 80 bit_acc=0.8948 delta=+0.0947 [flip=30% baseline=0.6988] t*= 5 bit_acc=0.8798 delta=+0.1810 t*= 10 bit_acc=0.8787 delta=+0.1799 t*= 20 bit_acc=0.8778 delta=+0.1789 t*= 40 bit_acc=0.8736 delta=+0.1748 t*= 80 bit_acc=0.8600 delta=+0.1612</a:t>
-            </a:r>
-            <a:endParaRPr lang="zh-CN" altLang="en-US" sz="1400" dirty="0"/>
+              <a:rPr lang="en-US" altLang="zh-CN" sz="1800" dirty="0"/>
+              <a:t>Pilot</a:t>
+            </a:r>
+            <a:r>
+              <a:rPr lang="zh-CN" altLang="en-US" sz="1800" dirty="0"/>
+              <a:t>实验记录：</a:t>
+            </a:r>
+          </a:p>
+          <a:p>
+            <a:r>
+              <a:rPr lang="en-US" altLang="zh-CN" sz="1800" dirty="0"/>
+              <a:t>- batch: 16</a:t>
+            </a:r>
+            <a:r>
+              <a:rPr lang="zh-CN" altLang="en-US" sz="1800" dirty="0"/>
+              <a:t>张图（</a:t>
+            </a:r>
+            <a:r>
+              <a:rPr lang="en-US" altLang="zh-CN" sz="1800" dirty="0"/>
+              <a:t>9</a:t>
+            </a:r>
+            <a:r>
+              <a:rPr lang="zh-CN" altLang="en-US" sz="1800" dirty="0"/>
+              <a:t>个真实框实例）</a:t>
+            </a:r>
+          </a:p>
+          <a:p>
+            <a:r>
+              <a:rPr lang="en-US" altLang="zh-CN" sz="1800" dirty="0"/>
+              <a:t>- eps=8/255, alpha=2/255, steps=10, </a:t>
+            </a:r>
+            <a:r>
+              <a:rPr lang="en-US" altLang="zh-CN" sz="1800" dirty="0" err="1"/>
+              <a:t>t_star</a:t>
+            </a:r>
+            <a:r>
+              <a:rPr lang="en-US" altLang="zh-CN" sz="1800" dirty="0"/>
+              <a:t>=40</a:t>
+            </a:r>
+          </a:p>
+          <a:p>
+            <a:r>
+              <a:rPr lang="en-US" altLang="zh-CN" sz="1800" dirty="0"/>
+              <a:t>- clean  mAP50=0.7301  mAP50-95=0.3622</a:t>
+            </a:r>
+          </a:p>
+          <a:p>
+            <a:r>
+              <a:rPr lang="en-US" altLang="zh-CN" sz="1800" dirty="0"/>
+              <a:t>- adv    mAP50=0.0243  mAP50-95=0.0069</a:t>
+            </a:r>
+          </a:p>
+          <a:p>
+            <a:r>
+              <a:rPr lang="en-US" altLang="zh-CN" sz="1800" dirty="0"/>
+              <a:t>- purified mAP50=0.2229 mAP50-95=0.0858</a:t>
+            </a:r>
+            <a:endParaRPr lang="zh-CN" altLang="en-US" sz="1800" dirty="0"/>
           </a:p>
         </p:txBody>
       </p:sp>
@@ -3708,7 +3857,7 @@
           <p:cNvPr id="2" name="标题 1">
             <a:extLst>
               <a:ext uri="{FF2B5EF4-FFF2-40B4-BE49-F238E27FC236}">
-                <a16:creationId xmlns:a16="http://schemas.microsoft.com/office/drawing/2014/main" id="{B9911F63-1061-F925-B7FE-242C9E42E2DB}"/>
+                <a16:creationId xmlns:a16="http://schemas.microsoft.com/office/drawing/2014/main" id="{78D48958-3A59-6588-0815-DEEA2D25868B}"/>
               </a:ext>
             </a:extLst>
           </p:cNvPr>
@@ -3733,7 +3882,7 @@
           <p:cNvPr id="3" name="内容占位符 2">
             <a:extLst>
               <a:ext uri="{FF2B5EF4-FFF2-40B4-BE49-F238E27FC236}">
-                <a16:creationId xmlns:a16="http://schemas.microsoft.com/office/drawing/2014/main" id="{295A1130-7D1A-742F-95CC-92E8FF68B30F}"/>
+                <a16:creationId xmlns:a16="http://schemas.microsoft.com/office/drawing/2014/main" id="{6F466E80-B3F0-B9F4-F4CB-EA9BFCF81EB2}"/>
               </a:ext>
             </a:extLst>
           </p:cNvPr>
@@ -3747,118 +3896,112 @@
         <p:spPr/>
         <p:txBody>
           <a:bodyPr>
-            <a:normAutofit fontScale="85000" lnSpcReduction="10000"/>
+            <a:normAutofit fontScale="85000" lnSpcReduction="20000"/>
           </a:bodyPr>
           <a:lstStyle/>
           <a:p>
             <a:r>
-              <a:rPr lang="zh-CN" altLang="zh-CN" sz="1700" dirty="0"/>
-              <a:t>这个batch里的框数量: 3</a:t>
-            </a:r>
-          </a:p>
-          <a:p>
-            <a:r>
-              <a:rPr lang="zh-CN" altLang="zh-CN" sz="1700" dirty="0"/>
-              <a:t>Class     Images  Instances      Box(P          R      mAP50  mAP50-95): 100% ━━━━━━━━━━━━ 2/2 2.1it/s 1.0s</a:t>
-            </a:r>
-          </a:p>
-          <a:p>
-            <a:r>
-              <a:rPr lang="zh-CN" altLang="zh-CN" sz="1700" dirty="0"/>
-              <a:t>                   all         23         12       0.86      0.381      0.533      0.258</a:t>
-            </a:r>
-          </a:p>
-          <a:p>
-            <a:r>
-              <a:rPr lang="zh-CN" altLang="zh-CN" sz="1700" dirty="0"/>
-              <a:t>Class     Images  Instances      Box(P          R      mAP50  mAP50-95): 100% ━━━━━━━━━━━━ 2/2 4.9it/s 0.4s</a:t>
-            </a:r>
-          </a:p>
-          <a:p>
-            <a:r>
-              <a:rPr lang="zh-CN" altLang="zh-CN" sz="1700" dirty="0"/>
-              <a:t>                   all         23         12     0.0302      0.143     0.0137    0.00409</a:t>
-            </a:r>
-          </a:p>
-          <a:p>
-            <a:r>
-              <a:rPr lang="zh-CN" altLang="zh-CN" sz="1700" dirty="0"/>
-              <a:t>adv         mAP50=0.0137  mAP50-95=0.0041</a:t>
-            </a:r>
-          </a:p>
-          <a:p>
-            <a:r>
-              <a:rPr lang="zh-CN" altLang="zh-CN" sz="1700" dirty="0"/>
-              <a:t>purified    mAP50=0.1178  mAP50-95=0.0412</a:t>
-            </a:r>
-          </a:p>
-          <a:p>
-            <a:r>
-              <a:rPr lang="en-US" altLang="zh-CN" sz="2100" dirty="0"/>
-              <a:t>Pilot</a:t>
-            </a:r>
-            <a:r>
-              <a:rPr lang="zh-CN" altLang="en-US" sz="2100" dirty="0"/>
-              <a:t>实验记录：</a:t>
-            </a:r>
-          </a:p>
-          <a:p>
-            <a:r>
-              <a:rPr lang="en-US" altLang="zh-CN" sz="2100" dirty="0"/>
-              <a:t>- batch: 16</a:t>
-            </a:r>
-            <a:r>
-              <a:rPr lang="zh-CN" altLang="en-US" sz="2100" dirty="0"/>
-              <a:t>张图（</a:t>
-            </a:r>
-            <a:r>
-              <a:rPr lang="en-US" altLang="zh-CN" sz="2100" dirty="0"/>
-              <a:t>9</a:t>
-            </a:r>
-            <a:r>
-              <a:rPr lang="zh-CN" altLang="en-US" sz="2100" dirty="0"/>
-              <a:t>个真实框实例）</a:t>
-            </a:r>
-          </a:p>
-          <a:p>
-            <a:r>
-              <a:rPr lang="en-US" altLang="zh-CN" sz="2100" dirty="0"/>
-              <a:t>- eps=8/255, alpha=2/255, steps=10, </a:t>
-            </a:r>
-            <a:r>
-              <a:rPr lang="en-US" altLang="zh-CN" sz="2100" dirty="0" err="1"/>
-              <a:t>t_star</a:t>
-            </a:r>
-            <a:r>
-              <a:rPr lang="en-US" altLang="zh-CN" sz="2100" dirty="0"/>
-              <a:t>=40</a:t>
-            </a:r>
-          </a:p>
-          <a:p>
-            <a:r>
-              <a:rPr lang="en-US" altLang="zh-CN" sz="2100" dirty="0"/>
-              <a:t>- clean  mAP50=0.7301  mAP50-95=0.3622</a:t>
-            </a:r>
-          </a:p>
-          <a:p>
-            <a:r>
-              <a:rPr lang="en-US" altLang="zh-CN" sz="2100" dirty="0"/>
-              <a:t>- adv    mAP50=0.0243  mAP50-95=0.0069</a:t>
-            </a:r>
-          </a:p>
-          <a:p>
-            <a:r>
-              <a:rPr lang="en-US" altLang="zh-CN" sz="2100" dirty="0"/>
-              <a:t>- purified mAP50=0.2229 mAP50-95=0.0858</a:t>
-            </a:r>
-            <a:endParaRPr lang="zh-CN" altLang="en-US" sz="2100" dirty="0"/>
+              <a:rPr lang="zh-CN" altLang="zh-CN" sz="1800" dirty="0"/>
+              <a:t>这个batch里的框数量: 9</a:t>
+            </a:r>
+          </a:p>
+          <a:p>
+            <a:r>
+              <a:rPr lang="zh-CN" altLang="zh-CN" sz="1800" b="1" dirty="0"/>
+              <a:t>val: </a:t>
+            </a:r>
+            <a:r>
+              <a:rPr lang="zh-CN" altLang="zh-CN" sz="1800" dirty="0"/>
+              <a:t>New cache created: /content/eval_clean/labels.cache</a:t>
+            </a:r>
+          </a:p>
+          <a:p>
+            <a:r>
+              <a:rPr lang="zh-CN" altLang="zh-CN" sz="1800" dirty="0"/>
+              <a:t>                 Class     Images  Instances      Box(P          R      mAP50  mAP50-95): 100% ━━━━━━━━━━━━ 4/4 2.7it/s 1.5s</a:t>
+            </a:r>
+          </a:p>
+          <a:p>
+            <a:r>
+              <a:rPr lang="zh-CN" altLang="zh-CN" sz="1800" dirty="0"/>
+              <a:t>                   all         62         69      0.554      0.551      0.528      0.306</a:t>
+            </a:r>
+          </a:p>
+          <a:p>
+            <a:r>
+              <a:rPr lang="zh-CN" altLang="zh-CN" sz="1800" dirty="0"/>
+              <a:t>adv         mAP50=0.0201  mAP50-95=0.0066</a:t>
+            </a:r>
+          </a:p>
+          <a:p>
+            <a:r>
+              <a:rPr lang="zh-CN" altLang="zh-CN" sz="1800" dirty="0"/>
+              <a:t>purified    mAP50=0.0588  mAP50-95=0.0173</a:t>
+            </a:r>
+            <a:endParaRPr lang="en-US" altLang="zh-CN" sz="1800" dirty="0"/>
+          </a:p>
+          <a:p>
+            <a:r>
+              <a:rPr lang="zh-CN" altLang="zh-CN" sz="1800" dirty="0"/>
+              <a:t>这个batch里的框数量: 14</a:t>
+            </a:r>
+          </a:p>
+          <a:p>
+            <a:r>
+              <a:rPr lang="zh-CN" altLang="zh-CN" sz="1800" b="1" dirty="0"/>
+              <a:t>val: </a:t>
+            </a:r>
+            <a:r>
+              <a:rPr lang="zh-CN" altLang="zh-CN" sz="1800" dirty="0"/>
+              <a:t>Scanning /content/eval_clean/labels... 31 images, 18 backgrounds, 0 corrupt: 100% ━━━━━━━━━━━━ 31/31 2.3Kit/s 0.0s</a:t>
+            </a:r>
+          </a:p>
+          <a:p>
+            <a:r>
+              <a:rPr lang="zh-CN" altLang="zh-CN" sz="1800" b="1" dirty="0"/>
+              <a:t>val: </a:t>
+            </a:r>
+            <a:r>
+              <a:rPr lang="zh-CN" altLang="zh-CN" sz="1800" dirty="0"/>
+              <a:t>New cache created: /content/eval_clean/labels.cache</a:t>
+            </a:r>
+          </a:p>
+          <a:p>
+            <a:r>
+              <a:rPr lang="zh-CN" altLang="zh-CN" sz="1800" dirty="0"/>
+              <a:t>                 Class     Images  Instances      Box(P          R      mAP50  mAP50-95): 100% ━━━━━━━━━━━━ 2/2 2.1it/s 1.0s</a:t>
+            </a:r>
+          </a:p>
+          <a:p>
+            <a:r>
+              <a:rPr lang="zh-CN" altLang="zh-CN" sz="1800" dirty="0"/>
+              <a:t>                   all         31         26      0.492      0.484      0.478      0.251</a:t>
+            </a:r>
+          </a:p>
+          <a:p>
+            <a:r>
+              <a:rPr lang="zh-CN" altLang="zh-CN" sz="1800" dirty="0"/>
+              <a:t>adv         mAP50=0.0124  mAP50-95=0.0043</a:t>
+            </a:r>
+          </a:p>
+          <a:p>
+            <a:r>
+              <a:rPr lang="zh-CN" altLang="zh-CN" sz="1800" dirty="0"/>
+              <a:t>purified    mAP50=0.0712  mAP50-95=0.0297</a:t>
+            </a:r>
+          </a:p>
+          <a:p>
+            <a:endParaRPr lang="zh-CN" altLang="zh-CN" sz="1800" dirty="0"/>
+          </a:p>
+          <a:p>
+            <a:endParaRPr lang="zh-CN" altLang="en-US" dirty="0"/>
           </a:p>
         </p:txBody>
       </p:sp>
     </p:spTree>
     <p:extLst>
       <p:ext uri="{BB962C8B-B14F-4D97-AF65-F5344CB8AC3E}">
-        <p14:creationId xmlns:p14="http://schemas.microsoft.com/office/powerpoint/2010/main" val="2840356058"/>
+        <p14:creationId xmlns:p14="http://schemas.microsoft.com/office/powerpoint/2010/main" val="173953949"/>
       </p:ext>
     </p:extLst>
   </p:cSld>
@@ -3890,7 +4033,7 @@
           <p:cNvPr id="2" name="标题 1">
             <a:extLst>
               <a:ext uri="{FF2B5EF4-FFF2-40B4-BE49-F238E27FC236}">
-                <a16:creationId xmlns:a16="http://schemas.microsoft.com/office/drawing/2014/main" id="{78D48958-3A59-6588-0815-DEEA2D25868B}"/>
+                <a16:creationId xmlns:a16="http://schemas.microsoft.com/office/drawing/2014/main" id="{E85BFE98-CAF5-EFDF-50D4-C77FE463BDCB}"/>
               </a:ext>
             </a:extLst>
           </p:cNvPr>
@@ -3899,31 +4042,6 @@
           </p:cNvSpPr>
           <p:nvPr>
             <p:ph type="title"/>
-          </p:nvPr>
-        </p:nvSpPr>
-        <p:spPr/>
-        <p:txBody>
-          <a:bodyPr/>
-          <a:lstStyle/>
-          <a:p>
-            <a:endParaRPr lang="zh-CN" altLang="en-US"/>
-          </a:p>
-        </p:txBody>
-      </p:sp>
-      <p:sp>
-        <p:nvSpPr>
-          <p:cNvPr id="3" name="内容占位符 2">
-            <a:extLst>
-              <a:ext uri="{FF2B5EF4-FFF2-40B4-BE49-F238E27FC236}">
-                <a16:creationId xmlns:a16="http://schemas.microsoft.com/office/drawing/2014/main" id="{6F466E80-B3F0-B9F4-F4CB-EA9BFCF81EB2}"/>
-              </a:ext>
-            </a:extLst>
-          </p:cNvPr>
-          <p:cNvSpPr>
-            <a:spLocks noGrp="1"/>
-          </p:cNvSpPr>
-          <p:nvPr>
-            <p:ph idx="1"/>
           </p:nvPr>
         </p:nvSpPr>
         <p:spPr/>
@@ -3934,181 +4052,395 @@
           <a:lstStyle/>
           <a:p>
             <a:r>
-              <a:rPr lang="zh-CN" altLang="zh-CN" sz="1800" dirty="0"/>
-              <a:t>这个batch里的框数量: 9</a:t>
-            </a:r>
-          </a:p>
-          <a:p>
-            <a:r>
-              <a:rPr lang="zh-CN" altLang="zh-CN" sz="1800" b="1" dirty="0"/>
-              <a:t>val: </a:t>
-            </a:r>
-            <a:r>
-              <a:rPr lang="zh-CN" altLang="zh-CN" sz="1800" dirty="0"/>
-              <a:t>New cache created: /content/eval_clean/labels.cache</a:t>
-            </a:r>
-          </a:p>
-          <a:p>
-            <a:r>
-              <a:rPr lang="zh-CN" altLang="zh-CN" sz="1800" dirty="0"/>
-              <a:t>                 Class     Images  Instances      Box(P          R      mAP50  mAP50-95): 100% ━━━━━━━━━━━━ 4/4 2.7it/s 1.5s</a:t>
-            </a:r>
-          </a:p>
-          <a:p>
-            <a:r>
-              <a:rPr lang="zh-CN" altLang="zh-CN" sz="1800" dirty="0"/>
-              <a:t>                   all         62         69      0.554      0.551      0.528      0.306</a:t>
-            </a:r>
-          </a:p>
-          <a:p>
-            <a:r>
-              <a:rPr lang="zh-CN" altLang="zh-CN" sz="1800" dirty="0"/>
-              <a:t>adv         mAP50=0.0201  mAP50-95=0.0066</a:t>
-            </a:r>
-          </a:p>
-          <a:p>
-            <a:r>
-              <a:rPr lang="zh-CN" altLang="zh-CN" sz="1800" dirty="0"/>
-              <a:t>purified    mAP50=0.0588  mAP50-95=0.0173</a:t>
-            </a:r>
-          </a:p>
-          <a:p>
-            <a:endParaRPr lang="zh-CN" altLang="en-US" dirty="0"/>
-          </a:p>
-        </p:txBody>
-      </p:sp>
-    </p:spTree>
-    <p:extLst>
-      <p:ext uri="{BB962C8B-B14F-4D97-AF65-F5344CB8AC3E}">
-        <p14:creationId xmlns:p14="http://schemas.microsoft.com/office/powerpoint/2010/main" val="173953949"/>
-      </p:ext>
-    </p:extLst>
-  </p:cSld>
-  <p:clrMapOvr>
-    <a:masterClrMapping/>
-  </p:clrMapOvr>
-</p:sld>
-</file>
-
-<file path=ppt/slides/slide6.xml><?xml version="1.0" encoding="utf-8"?>
-<p:sld xmlns:a="http://schemas.openxmlformats.org/drawingml/2006/main" xmlns:r="http://schemas.openxmlformats.org/officeDocument/2006/relationships" xmlns:p="http://schemas.openxmlformats.org/presentationml/2006/main">
-  <p:cSld>
-    <p:spTree>
-      <p:nvGrpSpPr>
-        <p:cNvPr id="1" name=""/>
-        <p:cNvGrpSpPr/>
-        <p:nvPr/>
-      </p:nvGrpSpPr>
-      <p:grpSpPr>
-        <a:xfrm>
-          <a:off x="0" y="0"/>
-          <a:ext cx="0" cy="0"/>
-          <a:chOff x="0" y="0"/>
-          <a:chExt cx="0" cy="0"/>
-        </a:xfrm>
-      </p:grpSpPr>
-      <p:sp>
-        <p:nvSpPr>
-          <p:cNvPr id="2" name="标题 1">
-            <a:extLst>
-              <a:ext uri="{FF2B5EF4-FFF2-40B4-BE49-F238E27FC236}">
-                <a16:creationId xmlns:a16="http://schemas.microsoft.com/office/drawing/2014/main" id="{E85BFE98-CAF5-EFDF-50D4-C77FE463BDCB}"/>
-              </a:ext>
-            </a:extLst>
-          </p:cNvPr>
-          <p:cNvSpPr>
-            <a:spLocks noGrp="1"/>
-          </p:cNvSpPr>
-          <p:nvPr>
-            <p:ph type="title"/>
-          </p:nvPr>
-        </p:nvSpPr>
-        <p:spPr/>
-        <p:txBody>
-          <a:bodyPr/>
-          <a:lstStyle/>
-          <a:p>
-            <a:endParaRPr lang="zh-CN" altLang="en-US"/>
-          </a:p>
-        </p:txBody>
-      </p:sp>
-      <p:sp>
-        <p:nvSpPr>
-          <p:cNvPr id="3" name="内容占位符 2">
-            <a:extLst>
-              <a:ext uri="{FF2B5EF4-FFF2-40B4-BE49-F238E27FC236}">
-                <a16:creationId xmlns:a16="http://schemas.microsoft.com/office/drawing/2014/main" id="{B9288EFB-9A5D-3988-9FEC-1031436FEDDB}"/>
-              </a:ext>
-            </a:extLst>
-          </p:cNvPr>
-          <p:cNvSpPr>
-            <a:spLocks noGrp="1"/>
-          </p:cNvSpPr>
-          <p:nvPr>
-            <p:ph idx="1"/>
-          </p:nvPr>
-        </p:nvSpPr>
-        <p:spPr/>
-        <p:txBody>
-          <a:bodyPr>
-            <a:normAutofit/>
-          </a:bodyPr>
-          <a:lstStyle/>
-          <a:p>
-            <a:r>
-              <a:rPr lang="zh-CN" altLang="zh-CN" sz="1900" dirty="0"/>
-              <a:t>这个batch里的框数量: 14</a:t>
-            </a:r>
-          </a:p>
-          <a:p>
-            <a:r>
-              <a:rPr lang="zh-CN" altLang="zh-CN" sz="1900" b="1" dirty="0"/>
-              <a:t>val: </a:t>
-            </a:r>
-            <a:r>
-              <a:rPr lang="zh-CN" altLang="zh-CN" sz="1900" dirty="0"/>
-              <a:t>Scanning /content/eval_clean/labels... 31 images, 18 backgrounds, 0 corrupt: 100% ━━━━━━━━━━━━ 31/31 2.3Kit/s 0.0s</a:t>
-            </a:r>
-          </a:p>
-          <a:p>
-            <a:r>
-              <a:rPr lang="zh-CN" altLang="zh-CN" sz="1900" b="1" dirty="0"/>
-              <a:t>val: </a:t>
-            </a:r>
-            <a:r>
-              <a:rPr lang="zh-CN" altLang="zh-CN" sz="1900" dirty="0"/>
-              <a:t>New cache created: /content/eval_clean/labels.cache</a:t>
-            </a:r>
-          </a:p>
-          <a:p>
-            <a:r>
-              <a:rPr lang="zh-CN" altLang="zh-CN" sz="1900" dirty="0"/>
-              <a:t>                 Class     Images  Instances      Box(P          R      mAP50  mAP50-95): 100% ━━━━━━━━━━━━ 2/2 2.1it/s 1.0s</a:t>
-            </a:r>
-          </a:p>
-          <a:p>
-            <a:r>
-              <a:rPr lang="zh-CN" altLang="zh-CN" sz="1900" dirty="0"/>
-              <a:t>                   all         31         26      0.492      0.484      0.478      0.251</a:t>
-            </a:r>
-          </a:p>
-          <a:p>
-            <a:r>
-              <a:rPr lang="zh-CN" altLang="zh-CN" sz="1900" dirty="0"/>
-              <a:t>adv         mAP50=0.0124  mAP50-95=0.0043</a:t>
-            </a:r>
-          </a:p>
-          <a:p>
-            <a:r>
-              <a:rPr lang="zh-CN" altLang="zh-CN" sz="1900" dirty="0"/>
-              <a:t>purified    mAP50=0.0712  mAP50-95=0.0297</a:t>
-            </a:r>
-          </a:p>
-          <a:p>
-            <a:endParaRPr lang="zh-CN" altLang="en-US" dirty="0"/>
-          </a:p>
-        </p:txBody>
-      </p:sp>
+              <a:rPr lang="zh-CN" altLang="en-US" sz="2800" dirty="0"/>
+              <a:t>完整测试集的</a:t>
+            </a:r>
+            <a:r>
+              <a:rPr lang="en-US" altLang="zh-CN" sz="2800" dirty="0" err="1"/>
+              <a:t>mAP</a:t>
+            </a:r>
+            <a:r>
+              <a:rPr lang="zh-CN" altLang="en-US" sz="2800" dirty="0"/>
+              <a:t>检测结果</a:t>
+            </a:r>
+          </a:p>
+        </p:txBody>
+      </p:sp>
+      <p:graphicFrame>
+        <p:nvGraphicFramePr>
+          <p:cNvPr id="5" name="表格 4">
+            <a:extLst>
+              <a:ext uri="{FF2B5EF4-FFF2-40B4-BE49-F238E27FC236}">
+                <a16:creationId xmlns:a16="http://schemas.microsoft.com/office/drawing/2014/main" id="{8E39D1B9-D6AC-D08B-0B5B-D2CCCFE85542}"/>
+              </a:ext>
+            </a:extLst>
+          </p:cNvPr>
+          <p:cNvGraphicFramePr>
+            <a:graphicFrameLocks noGrp="1"/>
+          </p:cNvGraphicFramePr>
+          <p:nvPr>
+            <p:extLst>
+              <p:ext uri="{D42A27DB-BD31-4B8C-83A1-F6EECF244321}">
+                <p14:modId xmlns:p14="http://schemas.microsoft.com/office/powerpoint/2010/main" val="90284534"/>
+              </p:ext>
+            </p:extLst>
+          </p:nvPr>
+        </p:nvGraphicFramePr>
+        <p:xfrm>
+          <a:off x="838200" y="1690688"/>
+          <a:ext cx="8128000" cy="1854200"/>
+        </p:xfrm>
+        <a:graphic>
+          <a:graphicData uri="http://schemas.openxmlformats.org/drawingml/2006/table">
+            <a:tbl>
+              <a:tblPr firstRow="1" bandRow="1">
+                <a:tableStyleId>{5C22544A-7EE6-4342-B048-85BDC9FD1C3A}</a:tableStyleId>
+              </a:tblPr>
+              <a:tblGrid>
+                <a:gridCol w="2032000">
+                  <a:extLst>
+                    <a:ext uri="{9D8B030D-6E8A-4147-A177-3AD203B41FA5}">
+                      <a16:colId xmlns:a16="http://schemas.microsoft.com/office/drawing/2014/main" val="2673749528"/>
+                    </a:ext>
+                  </a:extLst>
+                </a:gridCol>
+                <a:gridCol w="2032000">
+                  <a:extLst>
+                    <a:ext uri="{9D8B030D-6E8A-4147-A177-3AD203B41FA5}">
+                      <a16:colId xmlns:a16="http://schemas.microsoft.com/office/drawing/2014/main" val="4041282761"/>
+                    </a:ext>
+                  </a:extLst>
+                </a:gridCol>
+                <a:gridCol w="2032000">
+                  <a:extLst>
+                    <a:ext uri="{9D8B030D-6E8A-4147-A177-3AD203B41FA5}">
+                      <a16:colId xmlns:a16="http://schemas.microsoft.com/office/drawing/2014/main" val="1948831406"/>
+                    </a:ext>
+                  </a:extLst>
+                </a:gridCol>
+                <a:gridCol w="2032000">
+                  <a:extLst>
+                    <a:ext uri="{9D8B030D-6E8A-4147-A177-3AD203B41FA5}">
+                      <a16:colId xmlns:a16="http://schemas.microsoft.com/office/drawing/2014/main" val="2301681036"/>
+                    </a:ext>
+                  </a:extLst>
+                </a:gridCol>
+              </a:tblGrid>
+              <a:tr h="370840">
+                <a:tc>
+                  <a:txBody>
+                    <a:bodyPr/>
+                    <a:lstStyle/>
+                    <a:p>
+                      <a:endParaRPr lang="zh-CN" altLang="en-US"/>
+                    </a:p>
+                  </a:txBody>
+                  <a:tcPr/>
+                </a:tc>
+                <a:tc>
+                  <a:txBody>
+                    <a:bodyPr/>
+                    <a:lstStyle/>
+                    <a:p>
+                      <a:r>
+                        <a:rPr lang="en-US" altLang="zh-CN" dirty="0"/>
+                        <a:t>Precision</a:t>
+                      </a:r>
+                      <a:endParaRPr lang="zh-CN" altLang="en-US" dirty="0"/>
+                    </a:p>
+                  </a:txBody>
+                  <a:tcPr/>
+                </a:tc>
+                <a:tc>
+                  <a:txBody>
+                    <a:bodyPr/>
+                    <a:lstStyle/>
+                    <a:p>
+                      <a:r>
+                        <a:rPr lang="en-US" altLang="zh-CN" dirty="0"/>
+                        <a:t>Recall</a:t>
+                      </a:r>
+                      <a:endParaRPr lang="zh-CN" altLang="en-US" dirty="0"/>
+                    </a:p>
+                  </a:txBody>
+                  <a:tcPr/>
+                </a:tc>
+                <a:tc>
+                  <a:txBody>
+                    <a:bodyPr/>
+                    <a:lstStyle/>
+                    <a:p>
+                      <a:r>
+                        <a:rPr lang="en-US" altLang="zh-CN" dirty="0"/>
+                        <a:t>mAP50</a:t>
+                      </a:r>
+                      <a:endParaRPr lang="zh-CN" altLang="en-US" dirty="0"/>
+                    </a:p>
+                  </a:txBody>
+                  <a:tcPr/>
+                </a:tc>
+                <a:extLst>
+                  <a:ext uri="{0D108BD9-81ED-4DB2-BD59-A6C34878D82A}">
+                    <a16:rowId xmlns:a16="http://schemas.microsoft.com/office/drawing/2014/main" val="2213365057"/>
+                  </a:ext>
+                </a:extLst>
+              </a:tr>
+              <a:tr h="370840">
+                <a:tc>
+                  <a:txBody>
+                    <a:bodyPr/>
+                    <a:lstStyle/>
+                    <a:p>
+                      <a:r>
+                        <a:rPr lang="en-US" altLang="zh-CN" dirty="0"/>
+                        <a:t>clean</a:t>
+                      </a:r>
+                      <a:endParaRPr lang="zh-CN" altLang="en-US" dirty="0"/>
+                    </a:p>
+                  </a:txBody>
+                  <a:tcPr/>
+                </a:tc>
+                <a:tc>
+                  <a:txBody>
+                    <a:bodyPr/>
+                    <a:lstStyle/>
+                    <a:p>
+                      <a:r>
+                        <a:rPr lang="en-US" altLang="zh-CN" dirty="0"/>
+                        <a:t>0.597</a:t>
+                      </a:r>
+                      <a:endParaRPr lang="zh-CN" altLang="en-US" dirty="0"/>
+                    </a:p>
+                  </a:txBody>
+                  <a:tcPr/>
+                </a:tc>
+                <a:tc>
+                  <a:txBody>
+                    <a:bodyPr/>
+                    <a:lstStyle/>
+                    <a:p>
+                      <a:r>
+                        <a:rPr lang="en-US" altLang="zh-CN" dirty="0"/>
+                        <a:t>0.533</a:t>
+                      </a:r>
+                      <a:endParaRPr lang="zh-CN" altLang="en-US" dirty="0"/>
+                    </a:p>
+                  </a:txBody>
+                  <a:tcPr/>
+                </a:tc>
+                <a:tc>
+                  <a:txBody>
+                    <a:bodyPr/>
+                    <a:lstStyle/>
+                    <a:p>
+                      <a:r>
+                        <a:rPr lang="en-US" altLang="zh-CN" dirty="0"/>
+                        <a:t>0.557</a:t>
+                      </a:r>
+                      <a:endParaRPr lang="zh-CN" altLang="en-US" dirty="0"/>
+                    </a:p>
+                  </a:txBody>
+                  <a:tcPr/>
+                </a:tc>
+                <a:extLst>
+                  <a:ext uri="{0D108BD9-81ED-4DB2-BD59-A6C34878D82A}">
+                    <a16:rowId xmlns:a16="http://schemas.microsoft.com/office/drawing/2014/main" val="1633803726"/>
+                  </a:ext>
+                </a:extLst>
+              </a:tr>
+              <a:tr h="370840">
+                <a:tc>
+                  <a:txBody>
+                    <a:bodyPr/>
+                    <a:lstStyle/>
+                    <a:p>
+                      <a:r>
+                        <a:rPr lang="en-US" altLang="zh-CN" dirty="0"/>
+                        <a:t>adv</a:t>
+                      </a:r>
+                      <a:endParaRPr lang="zh-CN" altLang="en-US" dirty="0"/>
+                    </a:p>
+                  </a:txBody>
+                  <a:tcPr/>
+                </a:tc>
+                <a:tc>
+                  <a:txBody>
+                    <a:bodyPr/>
+                    <a:lstStyle/>
+                    <a:p>
+                      <a:r>
+                        <a:rPr lang="en-US" altLang="zh-CN" dirty="0"/>
+                        <a:t>0.133</a:t>
+                      </a:r>
+                      <a:endParaRPr lang="zh-CN" altLang="en-US" dirty="0"/>
+                    </a:p>
+                  </a:txBody>
+                  <a:tcPr/>
+                </a:tc>
+                <a:tc>
+                  <a:txBody>
+                    <a:bodyPr/>
+                    <a:lstStyle/>
+                    <a:p>
+                      <a:r>
+                        <a:rPr lang="en-US" altLang="zh-CN" dirty="0"/>
+                        <a:t>0.235</a:t>
+                      </a:r>
+                      <a:endParaRPr lang="zh-CN" altLang="en-US" dirty="0"/>
+                    </a:p>
+                  </a:txBody>
+                  <a:tcPr/>
+                </a:tc>
+                <a:tc>
+                  <a:txBody>
+                    <a:bodyPr/>
+                    <a:lstStyle/>
+                    <a:p>
+                      <a:r>
+                        <a:rPr lang="en-US" altLang="zh-CN" dirty="0"/>
+                        <a:t>0.076</a:t>
+                      </a:r>
+                      <a:endParaRPr lang="zh-CN" altLang="en-US" dirty="0"/>
+                    </a:p>
+                  </a:txBody>
+                  <a:tcPr/>
+                </a:tc>
+                <a:extLst>
+                  <a:ext uri="{0D108BD9-81ED-4DB2-BD59-A6C34878D82A}">
+                    <a16:rowId xmlns:a16="http://schemas.microsoft.com/office/drawing/2014/main" val="75176323"/>
+                  </a:ext>
+                </a:extLst>
+              </a:tr>
+              <a:tr h="370840">
+                <a:tc>
+                  <a:txBody>
+                    <a:bodyPr/>
+                    <a:lstStyle/>
+                    <a:p>
+                      <a:r>
+                        <a:rPr lang="en-US" altLang="zh-CN" dirty="0"/>
+                        <a:t>purified</a:t>
+                      </a:r>
+                      <a:endParaRPr lang="zh-CN" altLang="en-US" dirty="0"/>
+                    </a:p>
+                  </a:txBody>
+                  <a:tcPr/>
+                </a:tc>
+                <a:tc>
+                  <a:txBody>
+                    <a:bodyPr/>
+                    <a:lstStyle/>
+                    <a:p>
+                      <a:r>
+                        <a:rPr lang="en-US" altLang="zh-CN" dirty="0"/>
+                        <a:t>0.180</a:t>
+                      </a:r>
+                      <a:endParaRPr lang="zh-CN" altLang="en-US" dirty="0"/>
+                    </a:p>
+                  </a:txBody>
+                  <a:tcPr/>
+                </a:tc>
+                <a:tc>
+                  <a:txBody>
+                    <a:bodyPr/>
+                    <a:lstStyle/>
+                    <a:p>
+                      <a:r>
+                        <a:rPr lang="en-US" altLang="zh-CN" dirty="0"/>
+                        <a:t>0.149</a:t>
+                      </a:r>
+                      <a:endParaRPr lang="zh-CN" altLang="en-US" dirty="0"/>
+                    </a:p>
+                  </a:txBody>
+                  <a:tcPr/>
+                </a:tc>
+                <a:tc>
+                  <a:txBody>
+                    <a:bodyPr/>
+                    <a:lstStyle/>
+                    <a:p>
+                      <a:r>
+                        <a:rPr lang="en-US" altLang="zh-CN" dirty="0"/>
+                        <a:t>0.057</a:t>
+                      </a:r>
+                      <a:endParaRPr lang="zh-CN" altLang="en-US" dirty="0"/>
+                    </a:p>
+                  </a:txBody>
+                  <a:tcPr/>
+                </a:tc>
+                <a:extLst>
+                  <a:ext uri="{0D108BD9-81ED-4DB2-BD59-A6C34878D82A}">
+                    <a16:rowId xmlns:a16="http://schemas.microsoft.com/office/drawing/2014/main" val="4002533499"/>
+                  </a:ext>
+                </a:extLst>
+              </a:tr>
+              <a:tr h="370840">
+                <a:tc>
+                  <a:txBody>
+                    <a:bodyPr/>
+                    <a:lstStyle/>
+                    <a:p>
+                      <a:r>
+                        <a:rPr lang="en-US" altLang="zh-CN" dirty="0" err="1"/>
+                        <a:t>Ae_only</a:t>
+                      </a:r>
+                      <a:endParaRPr lang="zh-CN" altLang="en-US" dirty="0"/>
+                    </a:p>
+                  </a:txBody>
+                  <a:tcPr/>
+                </a:tc>
+                <a:tc>
+                  <a:txBody>
+                    <a:bodyPr/>
+                    <a:lstStyle/>
+                    <a:p>
+                      <a:r>
+                        <a:rPr lang="en-US" altLang="zh-CN" dirty="0"/>
+                        <a:t>0,229</a:t>
+                      </a:r>
+                      <a:endParaRPr lang="zh-CN" altLang="en-US" dirty="0"/>
+                    </a:p>
+                  </a:txBody>
+                  <a:tcPr/>
+                </a:tc>
+                <a:tc>
+                  <a:txBody>
+                    <a:bodyPr/>
+                    <a:lstStyle/>
+                    <a:p>
+                      <a:r>
+                        <a:rPr lang="en-US" altLang="zh-CN" dirty="0"/>
+                        <a:t>0.175</a:t>
+                      </a:r>
+                      <a:endParaRPr lang="zh-CN" altLang="en-US" dirty="0"/>
+                    </a:p>
+                  </a:txBody>
+                  <a:tcPr/>
+                </a:tc>
+                <a:tc>
+                  <a:txBody>
+                    <a:bodyPr/>
+                    <a:lstStyle/>
+                    <a:p>
+                      <a:r>
+                        <a:rPr lang="en-US" altLang="zh-CN" dirty="0"/>
+                        <a:t>0.082</a:t>
+                      </a:r>
+                      <a:endParaRPr lang="zh-CN" altLang="en-US" dirty="0"/>
+                    </a:p>
+                  </a:txBody>
+                  <a:tcPr/>
+                </a:tc>
+                <a:extLst>
+                  <a:ext uri="{0D108BD9-81ED-4DB2-BD59-A6C34878D82A}">
+                    <a16:rowId xmlns:a16="http://schemas.microsoft.com/office/drawing/2014/main" val="4066682578"/>
+                  </a:ext>
+                </a:extLst>
+              </a:tr>
+            </a:tbl>
+          </a:graphicData>
+        </a:graphic>
+      </p:graphicFrame>
     </p:spTree>
     <p:extLst>
       <p:ext uri="{BB962C8B-B14F-4D97-AF65-F5344CB8AC3E}">

</xml_diff>